<commit_message>
Rebuild course artifacts (17 files)
</commit_message>
<xml_diff>
--- a/vertebrate_neural_architecture/vertebrate_neural_architecture_lecture_1.pptx
+++ b/vertebrate_neural_architecture/vertebrate_neural_architecture_lecture_1.pptx
@@ -1100,37 +1100,31 @@
           <a:lstStyle/>
           <a:p>
             <a:r>
-              <a:t>This question puts the whole lecture's ledger into a machine.</a:t>
+              <a:t>This question turns the lecture's argument on machines, and the middle part of the question is the hard one.</a:t>
             </a:r>
           </a:p>
           <a:p/>
           <a:p>
             <a:r>
-              <a:t>A dense language model is the single-network answer. Every parameter takes part in processing every word, so everything the model learns is available everywhere. The cost is that every word pays for the whole network.</a:t>
+              <a:t>What would it mean for an AI program to be modular? Groups often answer by listing parts the builders designed: a language model is made of many repeated layers, and some models route each word to a few "expert" sub-networks. That is one sense of the word, and it is about the design. The sense that matters here is about the job: does one part do one job, connected to the rest through a limited set of links, so that it could be changed without redesigning everything else? A model can be divided by design and still not be divided by job. Its parts might all take part in everything.</a:t>
             </a:r>
           </a:p>
           <a:p/>
           <a:p>
             <a:r>
-              <a:t>A mixture-of-experts model is the separate-structures answer. The network is divided into many expert sub-networks, and a small router decides which few of them handle each word. Most of the network sits idle for any given word, which saves a great deal of computation. That is the energy cost of specialists, paid in silicon. But the design pays the other costs on the ledger. Something has to route, which is coordination. Experts that are not chosen do not learn from that word, so what one learns is not automatically shared. And training can go wrong if the router keeps sending everything to a few favorite experts, so builders add pressure to keep the choice balanced. That last problem is the second competing pair almost exactly, proposing strongly against comparing fairly: the choosing must not favor any one proposal.</a:t>
+              <a:t>How would we find out? The same ways we find out about a brain. Record what each part does while the system works. Damage or switch off one part and see what breaks, and what does not. Check whether a part can be swapped out without retraining the rest. These are the methods of neuroscience applied to a machine, and they come with the same trap: a part that is active during a task is not thereby the part that does the task.</a:t>
             </a:r>
           </a:p>
           <a:p/>
           <a:p>
             <a:r>
-              <a:t>The experts also tend not to divide their work as neatly as their name suggests. What each ends up doing emerges from training rather than being assigned in advance. That is the middle ground between separate structures and one network, where some specialization emerges through learning.</a:t>
+              <a:t>For language models, what researchers mostly find is the middle ground from this lecture. Something like specialization does appear, but it emerges from training rather than being built in, and the same units take part in many jobs. The next lecture comes back to that finding. So the honest answer to the first question is "partly, and it depends on what you mean", which is the same answer the lecture gave for brains.</a:t>
             </a:r>
           </a:p>
           <a:p/>
           <a:p>
             <a:r>
-              <a:t>The last question has a good answer and an important difference. The closest thing in a fish is the basal ganglia, which settle which proposed action is released. But a router decides where information goes. The basal ganglia decide which action gets out. One sends inputs to specialists. The other chooses among the specialists' outputs.</a:t>
-            </a:r>
-          </a:p>
-          <a:p/>
-          <a:p>
-            <a:r>
-              <a:t>If the room is quiet, a narrower version works: which of the two designs would be cheaper to run on a phone, and why?</a:t>
+              <a:t>If the room is quiet, narrow it: a phone keyboard that suggests the next word, and a chess program. Which seems more likely to have a part for each job, and how could we check?</a:t>
             </a:r>
           </a:p>
         </p:txBody>
@@ -1200,31 +1194,31 @@
           <a:lstStyle/>
           <a:p>
             <a:r>
-              <a:t>This is the first guiding question from the reading, turned toward things we already know.</a:t>
+              <a:t>This is the reading's first guiding question, asked about the brain directly. At the end of Module 5, one set of machinery was doing every job. Here the question is why a brain would not stay that way.</a:t>
             </a:r>
           </a:p>
           <a:p/>
           <a:p>
             <a:r>
-              <a:t>Good answers tend to come from ordinary life. A car tuned for speed handles badly in the snow. A knife sharp enough for fine work chips when it is used to pry. A person answering email all day cannot also do three hours of uninterrupted thinking. In each case, improving the one mechanism for one job makes it worse at the other.</a:t>
+              <a:t>The pros groups usually find are the ones the lecture builds toward. A part that does one job can be tuned to it. Two jobs in two parts cannot interfere with each other. And parts that work together constantly can sit close, so their wires stay short.</a:t>
             </a:r>
           </a:p>
           <a:p/>
           <a:p>
             <a:r>
-              <a:t>The second question is the one worth staying with. Splitting the jobs is the obvious fix, and it is never free. Two tools have to be carried and kept. Two people have to talk to each other, and someone has to decide what happens when they disagree.</a:t>
+              <a:t>The cons matter just as much, and they are easy to skip. Separate parts need wiring between them. They need some way of settling what happens when they disagree. And what one part learns is not automatically available to the others. One big network has the opposite profile: it shares everything it learns, but its jobs can get in each other's way.</a:t>
             </a:r>
           </a:p>
           <a:p/>
           <a:p>
             <a:r>
-              <a:t>Those two costs, the connections between the parts and a way of settling their disagreements, are exactly the costs the reading names for a nervous system. Separate parts need wiring between them. They also need some way of settling what happens when they disagree.</a:t>
+              <a:t>Dividing work also needs something to divide. The nematode of Modules 4 and 5 has 302 neurons in its whole body, which offers little to split. An animal with vastly more neurons can set some aside for one job and others for another.</a:t>
             </a:r>
           </a:p>
           <a:p/>
           <a:p>
             <a:r>
-              <a:t>Dividing work also needs something to divide. The nematode of Modules 4 and 5 has 302 neurons in its whole body, and that offers little to split. An animal with vastly more neurons can set some aside for one job and others for another.</a:t>
+              <a:t>One caution about the list on the slide. It mixes structures this module covers, such as the brainstem and the amygdala, with ones later modules take up, such as the hippocampus and the cortex. And naming a part is not the same as knowing its job, which the next lecture makes a point of.</a:t>
             </a:r>
           </a:p>
           <a:p/>
@@ -5911,7 +5905,7 @@
         </p:blipFill>
         <p:spPr>
           <a:xfrm>
-            <a:off x="1435608" y="1737360"/>
+            <a:off x="1435608" y="1627632"/>
             <a:ext cx="9319107" cy="4983480"/>
           </a:xfrm>
           <a:prstGeom prst="rect">
@@ -6218,7 +6212,7 @@
         <p:spPr>
           <a:xfrm>
             <a:off x="822960" y="1280160"/>
-            <a:ext cx="10515600" cy="4572000"/>
+            <a:ext cx="10515600" cy="2505456"/>
           </a:xfrm>
           <a:prstGeom prst="rect">
             <a:avLst/>
@@ -6264,49 +6258,7 @@
                 </a:solidFill>
                 <a:latin typeface="Calibri"/>
               </a:rPr>
-              <a:t>Some large AI language models are one network, with every part used for every word. Others are split into many "expert" sub-networks, and a router sends each word to just a few of them.</a:t>
-            </a:r>
-          </a:p>
-          <a:p>
-            <a:pPr>
-              <a:defRPr sz="1000"/>
-            </a:pPr>
-          </a:p>
-          <a:p>
-            <a:pPr>
-              <a:spcAft>
-                <a:spcPts val="2000"/>
-              </a:spcAft>
-            </a:pPr>
-            <a:r>
-              <a:rPr sz="2000" b="0" i="0">
-                <a:solidFill>
-                  <a:srgbClr val="222222"/>
-                </a:solidFill>
-                <a:latin typeface="Calibri"/>
-              </a:rPr>
-              <a:t>Using the ledger from this lecture: what does each design gain, and what does each pay?</a:t>
-            </a:r>
-          </a:p>
-          <a:p>
-            <a:pPr>
-              <a:defRPr sz="1000"/>
-            </a:pPr>
-          </a:p>
-          <a:p>
-            <a:pPr>
-              <a:spcAft>
-                <a:spcPts val="2000"/>
-              </a:spcAft>
-            </a:pPr>
-            <a:r>
-              <a:rPr sz="2000" b="0" i="0">
-                <a:solidFill>
-                  <a:srgbClr val="222222"/>
-                </a:solidFill>
-                <a:latin typeface="Calibri"/>
-              </a:rPr>
-              <a:t>What in a fish plays the part of the router, and how is it different?</a:t>
+              <a:t>Are AI programs, as far as you know, modular, or non-modular? What does that question even mean, and how would you go about finding an answer?</a:t>
             </a:r>
           </a:p>
         </p:txBody>
@@ -8102,7 +8054,7 @@
         <p:spPr>
           <a:xfrm>
             <a:off x="822960" y="1463040"/>
-            <a:ext cx="10515600" cy="4206240"/>
+            <a:ext cx="10515600" cy="2551176"/>
           </a:xfrm>
           <a:prstGeom prst="rect">
             <a:avLst/>
@@ -8148,49 +8100,7 @@
                 </a:solidFill>
                 <a:latin typeface="Calibri"/>
               </a:rPr>
-              <a:t>One mechanism that does everything is specialized for nothing.</a:t>
-            </a:r>
-          </a:p>
-          <a:p>
-            <a:pPr>
-              <a:defRPr sz="1000"/>
-            </a:pPr>
-          </a:p>
-          <a:p>
-            <a:pPr>
-              <a:spcAft>
-                <a:spcPts val="2400"/>
-              </a:spcAft>
-            </a:pPr>
-            <a:r>
-              <a:rPr sz="2000" b="0" i="0">
-                <a:solidFill>
-                  <a:srgbClr val="222222"/>
-                </a:solidFill>
-                <a:latin typeface="Calibri"/>
-              </a:rPr>
-              <a:t>Think of a tool, a machine, or a person asked to do two jobs, where getting better at one makes it worse at the other.</a:t>
-            </a:r>
-          </a:p>
-          <a:p>
-            <a:pPr>
-              <a:defRPr sz="1000"/>
-            </a:pPr>
-          </a:p>
-          <a:p>
-            <a:pPr>
-              <a:spcAft>
-                <a:spcPts val="2400"/>
-              </a:spcAft>
-            </a:pPr>
-            <a:r>
-              <a:rPr sz="2000" b="0" i="0">
-                <a:solidFill>
-                  <a:srgbClr val="222222"/>
-                </a:solidFill>
-                <a:latin typeface="Calibri"/>
-              </a:rPr>
-              <a:t>Should the jobs be split? What would splitting them cost?</a:t>
+              <a:t>The brain has different parts. A thalamus, amygdala, hippocampus, brainstem, cortex. Why? What are the pros and cons of splitting up into parts, rather than one big neural network?</a:t>
             </a:r>
           </a:p>
         </p:txBody>

</xml_diff>